<commit_message>
deploy: bake live URLs (Vercel + Render) into slides + widen API CORS regex
</commit_message>
<xml_diff>
--- a/presentation/slides.pptx
+++ b/presentation/slides.pptx
@@ -34437,8 +34437,8 @@
         </p:nvSpPr>
         <p:spPr>
           <a:xfrm>
-            <a:off x="-360" y="-360"/>
-            <a:ext cx="5760720" cy="720720"/>
+            <a:off x="-360" y="0"/>
+            <a:ext cx="5760720" cy="720360"/>
           </a:xfrm>
           <a:custGeom>
             <a:avLst/>
@@ -34446,9 +34446,9 @@
             <a:ahLst/>
             <a:rect l="0" t="0" r="r" b="b"/>
             <a:pathLst>
-              <a:path w="16002" h="2002">
+              <a:path w="16002" h="2001">
                 <a:moveTo>
-                  <a:pt x="0" y="2002"/>
+                  <a:pt x="0" y="2001"/>
                 </a:moveTo>
                 <a:lnTo>
                   <a:pt x="0" y="0"/>
@@ -34457,10 +34457,10 @@
                   <a:pt x="16002" y="0"/>
                 </a:lnTo>
                 <a:lnTo>
-                  <a:pt x="16002" y="2002"/>
-                </a:lnTo>
-                <a:lnTo>
-                  <a:pt x="0" y="2002"/>
+                  <a:pt x="16002" y="2001"/>
+                </a:lnTo>
+                <a:lnTo>
+                  <a:pt x="0" y="2001"/>
                 </a:lnTo>
                 <a:close/>
               </a:path>
@@ -34606,7 +34606,7 @@
         </p:nvSpPr>
         <p:spPr>
           <a:xfrm>
-            <a:off x="1681200" y="590760"/>
+            <a:off x="1681200" y="604440"/>
             <a:ext cx="2494080" cy="687600"/>
           </a:xfrm>
           <a:prstGeom prst="rect">
@@ -34649,7 +34649,7 @@
         </p:nvSpPr>
         <p:spPr>
           <a:xfrm>
-            <a:off x="359640" y="2189160"/>
+            <a:off x="359640" y="2203200"/>
             <a:ext cx="1613520" cy="397080"/>
           </a:xfrm>
           <a:custGeom>
@@ -34660,10 +34660,10 @@
             <a:pathLst>
               <a:path w="4482" h="1103">
                 <a:moveTo>
-                  <a:pt x="0" y="962"/>
+                  <a:pt x="0" y="961"/>
                 </a:moveTo>
                 <a:lnTo>
-                  <a:pt x="0" y="141"/>
+                  <a:pt x="0" y="140"/>
                 </a:lnTo>
                 <a:cubicBezTo>
                   <a:pt x="0" y="63"/>
@@ -34676,13 +34676,13 @@
                 <a:cubicBezTo>
                   <a:pt x="4419" y="0"/>
                   <a:pt x="4482" y="63"/>
-                  <a:pt x="4482" y="141"/>
+                  <a:pt x="4482" y="140"/>
                 </a:cubicBezTo>
                 <a:lnTo>
-                  <a:pt x="4482" y="962"/>
+                  <a:pt x="4482" y="961"/>
                 </a:lnTo>
                 <a:cubicBezTo>
-                  <a:pt x="4482" y="1039"/>
+                  <a:pt x="4482" y="1040"/>
                   <a:pt x="4419" y="1103"/>
                   <a:pt x="4341" y="1103"/>
                 </a:cubicBezTo>
@@ -34691,8 +34691,8 @@
                 </a:lnTo>
                 <a:cubicBezTo>
                   <a:pt x="63" y="1103"/>
-                  <a:pt x="0" y="1039"/>
-                  <a:pt x="0" y="962"/>
+                  <a:pt x="0" y="1040"/>
+                  <a:pt x="0" y="961"/>
                 </a:cubicBezTo>
                 <a:close/>
               </a:path>
@@ -34727,7 +34727,7 @@
         </p:nvSpPr>
         <p:spPr>
           <a:xfrm>
-            <a:off x="359640" y="2189160"/>
+            <a:off x="359640" y="2203200"/>
             <a:ext cx="1613520" cy="397080"/>
           </a:xfrm>
           <a:custGeom>
@@ -34738,10 +34738,10 @@
             <a:pathLst>
               <a:path w="4482" h="1103">
                 <a:moveTo>
-                  <a:pt x="0" y="962"/>
+                  <a:pt x="0" y="961"/>
                 </a:moveTo>
                 <a:lnTo>
-                  <a:pt x="0" y="141"/>
+                  <a:pt x="0" y="140"/>
                 </a:lnTo>
                 <a:cubicBezTo>
                   <a:pt x="0" y="63"/>
@@ -34754,13 +34754,13 @@
                 <a:cubicBezTo>
                   <a:pt x="4419" y="0"/>
                   <a:pt x="4482" y="63"/>
-                  <a:pt x="4482" y="141"/>
+                  <a:pt x="4482" y="140"/>
                 </a:cubicBezTo>
                 <a:lnTo>
-                  <a:pt x="4482" y="962"/>
+                  <a:pt x="4482" y="961"/>
                 </a:lnTo>
                 <a:cubicBezTo>
-                  <a:pt x="4482" y="1039"/>
+                  <a:pt x="4482" y="1040"/>
                   <a:pt x="4419" y="1103"/>
                   <a:pt x="4341" y="1103"/>
                 </a:cubicBezTo>
@@ -34769,8 +34769,8 @@
                 </a:lnTo>
                 <a:cubicBezTo>
                   <a:pt x="63" y="1103"/>
-                  <a:pt x="0" y="1039"/>
-                  <a:pt x="0" y="962"/>
+                  <a:pt x="0" y="1040"/>
+                  <a:pt x="0" y="961"/>
                 </a:cubicBezTo>
                 <a:close/>
               </a:path>
@@ -34805,7 +34805,7 @@
         </p:nvSpPr>
         <p:spPr>
           <a:xfrm>
-            <a:off x="2005560" y="1325160"/>
+            <a:off x="2005560" y="1338840"/>
             <a:ext cx="1755000" cy="267120"/>
           </a:xfrm>
           <a:prstGeom prst="rect">
@@ -34848,7 +34848,7 @@
         </p:nvSpPr>
         <p:spPr>
           <a:xfrm>
-            <a:off x="1099440" y="2246040"/>
+            <a:off x="1099440" y="2259720"/>
             <a:ext cx="138240" cy="189360"/>
           </a:xfrm>
           <a:prstGeom prst="rect">
@@ -34891,8 +34891,8 @@
         </p:nvSpPr>
         <p:spPr>
           <a:xfrm>
-            <a:off x="2073240" y="2189160"/>
-            <a:ext cx="1613520" cy="379080"/>
+            <a:off x="2073240" y="2203200"/>
+            <a:ext cx="1613520" cy="378720"/>
           </a:xfrm>
           <a:custGeom>
             <a:avLst/>
@@ -34900,12 +34900,12 @@
             <a:ahLst/>
             <a:rect l="0" t="0" r="r" b="b"/>
             <a:pathLst>
-              <a:path w="4482" h="1053">
+              <a:path w="4482" h="1052">
                 <a:moveTo>
                   <a:pt x="0" y="912"/>
                 </a:moveTo>
                 <a:lnTo>
-                  <a:pt x="0" y="141"/>
+                  <a:pt x="0" y="140"/>
                 </a:lnTo>
                 <a:cubicBezTo>
                   <a:pt x="0" y="63"/>
@@ -34918,22 +34918,22 @@
                 <a:cubicBezTo>
                   <a:pt x="4419" y="0"/>
                   <a:pt x="4482" y="63"/>
-                  <a:pt x="4482" y="141"/>
+                  <a:pt x="4482" y="140"/>
                 </a:cubicBezTo>
                 <a:lnTo>
                   <a:pt x="4482" y="912"/>
                 </a:lnTo>
                 <a:cubicBezTo>
-                  <a:pt x="4482" y="990"/>
-                  <a:pt x="4419" y="1053"/>
-                  <a:pt x="4341" y="1053"/>
+                  <a:pt x="4482" y="989"/>
+                  <a:pt x="4419" y="1052"/>
+                  <a:pt x="4341" y="1052"/>
                 </a:cubicBezTo>
                 <a:lnTo>
-                  <a:pt x="141" y="1053"/>
+                  <a:pt x="141" y="1052"/>
                 </a:lnTo>
                 <a:cubicBezTo>
-                  <a:pt x="63" y="1053"/>
-                  <a:pt x="0" y="990"/>
+                  <a:pt x="63" y="1052"/>
+                  <a:pt x="0" y="989"/>
                   <a:pt x="0" y="912"/>
                 </a:cubicBezTo>
                 <a:close/>
@@ -34969,8 +34969,8 @@
         </p:nvSpPr>
         <p:spPr>
           <a:xfrm>
-            <a:off x="2073240" y="2189160"/>
-            <a:ext cx="1613520" cy="379080"/>
+            <a:off x="2073240" y="2203200"/>
+            <a:ext cx="1613520" cy="378720"/>
           </a:xfrm>
           <a:custGeom>
             <a:avLst/>
@@ -34978,12 +34978,12 @@
             <a:ahLst/>
             <a:rect l="0" t="0" r="r" b="b"/>
             <a:pathLst>
-              <a:path w="4482" h="1053">
+              <a:path w="4482" h="1052">
                 <a:moveTo>
                   <a:pt x="0" y="912"/>
                 </a:moveTo>
                 <a:lnTo>
-                  <a:pt x="0" y="141"/>
+                  <a:pt x="0" y="140"/>
                 </a:lnTo>
                 <a:cubicBezTo>
                   <a:pt x="0" y="63"/>
@@ -34996,22 +34996,22 @@
                 <a:cubicBezTo>
                   <a:pt x="4419" y="0"/>
                   <a:pt x="4482" y="63"/>
-                  <a:pt x="4482" y="141"/>
+                  <a:pt x="4482" y="140"/>
                 </a:cubicBezTo>
                 <a:lnTo>
                   <a:pt x="4482" y="912"/>
                 </a:lnTo>
                 <a:cubicBezTo>
-                  <a:pt x="4482" y="990"/>
-                  <a:pt x="4419" y="1053"/>
-                  <a:pt x="4341" y="1053"/>
+                  <a:pt x="4482" y="989"/>
+                  <a:pt x="4419" y="1052"/>
+                  <a:pt x="4341" y="1052"/>
                 </a:cubicBezTo>
                 <a:lnTo>
-                  <a:pt x="141" y="1053"/>
+                  <a:pt x="141" y="1052"/>
                 </a:lnTo>
                 <a:cubicBezTo>
-                  <a:pt x="63" y="1053"/>
-                  <a:pt x="0" y="990"/>
+                  <a:pt x="63" y="1052"/>
+                  <a:pt x="0" y="989"/>
                   <a:pt x="0" y="912"/>
                 </a:cubicBezTo>
                 <a:close/>
@@ -35047,7 +35047,7 @@
         </p:nvSpPr>
         <p:spPr>
           <a:xfrm>
-            <a:off x="591840" y="2405880"/>
+            <a:off x="591840" y="2419560"/>
             <a:ext cx="1172520" cy="102600"/>
           </a:xfrm>
           <a:prstGeom prst="rect">
@@ -35090,7 +35090,7 @@
         </p:nvSpPr>
         <p:spPr>
           <a:xfrm>
-            <a:off x="2810880" y="2232000"/>
+            <a:off x="2810880" y="2245680"/>
             <a:ext cx="138240" cy="189360"/>
           </a:xfrm>
           <a:prstGeom prst="rect">
@@ -35133,8 +35133,8 @@
         </p:nvSpPr>
         <p:spPr>
           <a:xfrm>
-            <a:off x="3786840" y="2189160"/>
-            <a:ext cx="1613520" cy="432720"/>
+            <a:off x="3786840" y="2203200"/>
+            <a:ext cx="1613520" cy="397800"/>
           </a:xfrm>
           <a:custGeom>
             <a:avLst/>
@@ -35142,12 +35142,12 @@
             <a:ahLst/>
             <a:rect l="0" t="0" r="r" b="b"/>
             <a:pathLst>
-              <a:path w="4482" h="1202">
+              <a:path w="4482" h="1105">
                 <a:moveTo>
-                  <a:pt x="0" y="1061"/>
+                  <a:pt x="0" y="964"/>
                 </a:moveTo>
                 <a:lnTo>
-                  <a:pt x="0" y="141"/>
+                  <a:pt x="0" y="140"/>
                 </a:lnTo>
                 <a:cubicBezTo>
                   <a:pt x="0" y="63"/>
@@ -35160,23 +35160,23 @@
                 <a:cubicBezTo>
                   <a:pt x="4419" y="0"/>
                   <a:pt x="4482" y="63"/>
-                  <a:pt x="4482" y="141"/>
+                  <a:pt x="4482" y="140"/>
                 </a:cubicBezTo>
                 <a:lnTo>
-                  <a:pt x="4482" y="1061"/>
+                  <a:pt x="4482" y="964"/>
                 </a:lnTo>
                 <a:cubicBezTo>
-                  <a:pt x="4482" y="1139"/>
-                  <a:pt x="4419" y="1202"/>
-                  <a:pt x="4341" y="1202"/>
+                  <a:pt x="4482" y="1041"/>
+                  <a:pt x="4419" y="1105"/>
+                  <a:pt x="4341" y="1105"/>
                 </a:cubicBezTo>
                 <a:lnTo>
-                  <a:pt x="141" y="1202"/>
+                  <a:pt x="141" y="1105"/>
                 </a:lnTo>
                 <a:cubicBezTo>
-                  <a:pt x="63" y="1202"/>
-                  <a:pt x="0" y="1139"/>
-                  <a:pt x="0" y="1061"/>
+                  <a:pt x="63" y="1105"/>
+                  <a:pt x="0" y="1041"/>
+                  <a:pt x="0" y="964"/>
                 </a:cubicBezTo>
                 <a:close/>
               </a:path>
@@ -35211,8 +35211,8 @@
         </p:nvSpPr>
         <p:spPr>
           <a:xfrm>
-            <a:off x="3786840" y="2189160"/>
-            <a:ext cx="1613520" cy="432720"/>
+            <a:off x="3786840" y="2203200"/>
+            <a:ext cx="1613520" cy="397800"/>
           </a:xfrm>
           <a:custGeom>
             <a:avLst/>
@@ -35220,12 +35220,12 @@
             <a:ahLst/>
             <a:rect l="0" t="0" r="r" b="b"/>
             <a:pathLst>
-              <a:path w="4482" h="1202">
+              <a:path w="4482" h="1105">
                 <a:moveTo>
-                  <a:pt x="0" y="1061"/>
+                  <a:pt x="0" y="964"/>
                 </a:moveTo>
                 <a:lnTo>
-                  <a:pt x="0" y="141"/>
+                  <a:pt x="0" y="140"/>
                 </a:lnTo>
                 <a:cubicBezTo>
                   <a:pt x="0" y="63"/>
@@ -35238,23 +35238,23 @@
                 <a:cubicBezTo>
                   <a:pt x="4419" y="0"/>
                   <a:pt x="4482" y="63"/>
-                  <a:pt x="4482" y="141"/>
+                  <a:pt x="4482" y="140"/>
                 </a:cubicBezTo>
                 <a:lnTo>
-                  <a:pt x="4482" y="1061"/>
+                  <a:pt x="4482" y="964"/>
                 </a:lnTo>
                 <a:cubicBezTo>
-                  <a:pt x="4482" y="1139"/>
-                  <a:pt x="4419" y="1202"/>
-                  <a:pt x="4341" y="1202"/>
+                  <a:pt x="4482" y="1041"/>
+                  <a:pt x="4419" y="1105"/>
+                  <a:pt x="4341" y="1105"/>
                 </a:cubicBezTo>
                 <a:lnTo>
-                  <a:pt x="141" y="1202"/>
+                  <a:pt x="141" y="1105"/>
                 </a:lnTo>
                 <a:cubicBezTo>
-                  <a:pt x="63" y="1202"/>
-                  <a:pt x="0" y="1139"/>
-                  <a:pt x="0" y="1061"/>
+                  <a:pt x="63" y="1105"/>
+                  <a:pt x="0" y="1041"/>
+                  <a:pt x="0" y="964"/>
                 </a:cubicBezTo>
                 <a:close/>
               </a:path>
@@ -35289,7 +35289,7 @@
         </p:nvSpPr>
         <p:spPr>
           <a:xfrm>
-            <a:off x="2402640" y="2381040"/>
+            <a:off x="2402640" y="2394720"/>
             <a:ext cx="957960" cy="113400"/>
           </a:xfrm>
           <a:prstGeom prst="rect">
@@ -35332,7 +35332,7 @@
         </p:nvSpPr>
         <p:spPr>
           <a:xfrm>
-            <a:off x="4526640" y="2247120"/>
+            <a:off x="4526640" y="2260800"/>
             <a:ext cx="138240" cy="189360"/>
           </a:xfrm>
           <a:prstGeom prst="rect">
@@ -35375,73 +35375,73 @@
         </p:nvSpPr>
         <p:spPr>
           <a:xfrm>
-            <a:off x="4076640" y="2398320"/>
-            <a:ext cx="980640" cy="148320"/>
-          </a:xfrm>
-          <a:prstGeom prst="rect">
-            <a:avLst/>
-          </a:prstGeom>
-          <a:noFill/>
-          <a:ln w="0">
-            <a:noFill/>
-          </a:ln>
-        </p:spPr>
-        <p:txBody>
-          <a:bodyPr wrap="none" lIns="0" rIns="0" tIns="0" bIns="0" anchor="t">
-            <a:noAutofit/>
-          </a:bodyPr>
-          <a:p>
-            <a:r>
-              <a:rPr b="0" lang="en-US" sz="790" spc="-1" strike="noStrike">
+            <a:off x="4049280" y="2420640"/>
+            <a:ext cx="1091880" cy="102600"/>
+          </a:xfrm>
+          <a:prstGeom prst="rect">
+            <a:avLst/>
+          </a:prstGeom>
+          <a:noFill/>
+          <a:ln w="0">
+            <a:noFill/>
+          </a:ln>
+        </p:spPr>
+        <p:txBody>
+          <a:bodyPr wrap="none" lIns="0" rIns="0" tIns="0" bIns="0" anchor="t">
+            <a:noAutofit/>
+          </a:bodyPr>
+          <a:p>
+            <a:r>
+              <a:rPr b="0" lang="en-US" sz="600" spc="-1" strike="noStrike">
                 <a:solidFill>
                   <a:srgbClr val="ffffff"/>
+                </a:solidFill>
+                <a:latin typeface="LMMono8"/>
+                <a:ea typeface="LMMono8"/>
+              </a:rPr>
+              <a:t>scm-policy-india.vercel.app</a:t>
+            </a:r>
+            <a:endParaRPr b="0" lang="en-US" sz="600" spc="-1" strike="noStrike">
+              <a:solidFill>
+                <a:srgbClr val="000000"/>
+              </a:solidFill>
+              <a:latin typeface="Times New Roman"/>
+            </a:endParaRPr>
+          </a:p>
+        </p:txBody>
+      </p:sp>
+      <p:sp>
+        <p:nvSpPr>
+          <p:cNvPr id="1021" name=""/>
+          <p:cNvSpPr txBox="1"/>
+          <p:nvPr/>
+        </p:nvSpPr>
+        <p:spPr>
+          <a:xfrm>
+            <a:off x="1838880" y="2902680"/>
+            <a:ext cx="858600" cy="113400"/>
+          </a:xfrm>
+          <a:prstGeom prst="rect">
+            <a:avLst/>
+          </a:prstGeom>
+          <a:noFill/>
+          <a:ln w="0">
+            <a:noFill/>
+          </a:ln>
+        </p:spPr>
+        <p:txBody>
+          <a:bodyPr wrap="none" lIns="0" rIns="0" tIns="0" bIns="0" anchor="t">
+            <a:noAutofit/>
+          </a:bodyPr>
+          <a:p>
+            <a:r>
+              <a:rPr b="0" lang="en-US" sz="600" spc="-1" strike="noStrike">
+                <a:solidFill>
+                  <a:srgbClr val="e5e7eb"/>
                 </a:solidFill>
                 <a:latin typeface="LMSans8"/>
                 <a:ea typeface="LMSans8"/>
               </a:rPr>
-              <a:t>live demo — see repo</a:t>
-            </a:r>
-            <a:endParaRPr b="0" lang="en-US" sz="790" spc="-1" strike="noStrike">
-              <a:solidFill>
-                <a:srgbClr val="000000"/>
-              </a:solidFill>
-              <a:latin typeface="Times New Roman"/>
-            </a:endParaRPr>
-          </a:p>
-        </p:txBody>
-      </p:sp>
-      <p:sp>
-        <p:nvSpPr>
-          <p:cNvPr id="1021" name=""/>
-          <p:cNvSpPr txBox="1"/>
-          <p:nvPr/>
-        </p:nvSpPr>
-        <p:spPr>
-          <a:xfrm>
-            <a:off x="1838880" y="2923200"/>
-            <a:ext cx="858600" cy="113400"/>
-          </a:xfrm>
-          <a:prstGeom prst="rect">
-            <a:avLst/>
-          </a:prstGeom>
-          <a:noFill/>
-          <a:ln w="0">
-            <a:noFill/>
-          </a:ln>
-        </p:spPr>
-        <p:txBody>
-          <a:bodyPr wrap="none" lIns="0" rIns="0" tIns="0" bIns="0" anchor="t">
-            <a:noAutofit/>
-          </a:bodyPr>
-          <a:p>
-            <a:r>
-              <a:rPr b="0" lang="en-US" sz="600" spc="-1" strike="noStrike">
-                <a:solidFill>
-                  <a:srgbClr val="e5e7eb"/>
-                </a:solidFill>
-                <a:latin typeface="LMSans8"/>
-                <a:ea typeface="LMSans8"/>
-              </a:rPr>
               <a:t>Mohammed Talha Ansari</a:t>
             </a:r>
             <a:endParaRPr b="0" lang="en-US" sz="600" spc="-1" strike="noStrike">
@@ -35461,7 +35461,7 @@
         </p:nvSpPr>
         <p:spPr>
           <a:xfrm>
-            <a:off x="2753280" y="2929680"/>
+            <a:off x="2753280" y="2909160"/>
             <a:ext cx="75600" cy="104040"/>
           </a:xfrm>
           <a:prstGeom prst="rect">
@@ -35504,7 +35504,7 @@
         </p:nvSpPr>
         <p:spPr>
           <a:xfrm>
-            <a:off x="2849040" y="2923200"/>
+            <a:off x="2849040" y="2902680"/>
             <a:ext cx="1075320" cy="113400"/>
           </a:xfrm>
           <a:prstGeom prst="rect">

</xml_diff>